<commit_message>
Redesign Title Slide 1 with luxury Presidential split hero layout and official government ribbon
</commit_message>
<xml_diff>
--- a/NCCIA_Officer_Operational_CMS_Presentation.pptx
+++ b/NCCIA_Officer_Operational_CMS_Presentation.pptx
@@ -3146,14 +3146,159 @@
       </p:sp>
       <p:sp>
         <p:nvSpPr>
-          <p:cNvPr id="3" name="Oval 2"/>
+          <p:cNvPr id="3" name="Rounded Rectangle 2"/>
           <p:cNvSpPr/>
           <p:nvPr/>
         </p:nvSpPr>
         <p:spPr>
           <a:xfrm>
-            <a:off x="4925415" y="658368"/>
-            <a:ext cx="2340864" cy="2340864"/>
+            <a:off x="548640" y="457200"/>
+            <a:ext cx="11094415" cy="5943600"/>
+          </a:xfrm>
+          <a:prstGeom prst="roundRect">
+            <a:avLst/>
+          </a:prstGeom>
+          <a:solidFill>
+            <a:srgbClr val="0E1C36"/>
+          </a:solidFill>
+          <a:ln w="25400">
+            <a:solidFill>
+              <a:srgbClr val="294A6E"/>
+            </a:solidFill>
+          </a:ln>
+        </p:spPr>
+        <p:style>
+          <a:lnRef idx="1">
+            <a:schemeClr val="accent1"/>
+          </a:lnRef>
+          <a:fillRef idx="3">
+            <a:schemeClr val="accent1"/>
+          </a:fillRef>
+          <a:effectRef idx="2">
+            <a:schemeClr val="accent1"/>
+          </a:effectRef>
+          <a:fontRef idx="minor">
+            <a:schemeClr val="lt1"/>
+          </a:fontRef>
+        </p:style>
+        <p:txBody>
+          <a:bodyPr rtlCol="0" anchor="ctr"/>
+          <a:lstStyle/>
+          <a:p>
+            <a:pPr algn="ctr"/>
+          </a:p>
+        </p:txBody>
+      </p:sp>
+      <p:sp>
+        <p:nvSpPr>
+          <p:cNvPr id="4" name="Rounded Rectangle 3"/>
+          <p:cNvSpPr/>
+          <p:nvPr/>
+        </p:nvSpPr>
+        <p:spPr>
+          <a:xfrm>
+            <a:off x="914400" y="777240"/>
+            <a:ext cx="10362895" cy="502920"/>
+          </a:xfrm>
+          <a:prstGeom prst="roundRect">
+            <a:avLst/>
+          </a:prstGeom>
+          <a:solidFill>
+            <a:srgbClr val="0A1426"/>
+          </a:solidFill>
+          <a:ln w="15240">
+            <a:solidFill>
+              <a:srgbClr val="E5B953"/>
+            </a:solidFill>
+          </a:ln>
+        </p:spPr>
+        <p:style>
+          <a:lnRef idx="1">
+            <a:schemeClr val="accent1"/>
+          </a:lnRef>
+          <a:fillRef idx="3">
+            <a:schemeClr val="accent1"/>
+          </a:fillRef>
+          <a:effectRef idx="2">
+            <a:schemeClr val="accent1"/>
+          </a:effectRef>
+          <a:fontRef idx="minor">
+            <a:schemeClr val="lt1"/>
+          </a:fontRef>
+        </p:style>
+        <p:txBody>
+          <a:bodyPr rtlCol="0" anchor="ctr" wrap="square" tIns="73152"/>
+          <a:lstStyle/>
+          <a:p>
+            <a:pPr algn="ctr">
+              <a:defRPr sz="1200" b="1">
+                <a:solidFill>
+                  <a:srgbClr val="E5B953"/>
+                </a:solidFill>
+                <a:latin typeface="Segoe UI"/>
+              </a:defRPr>
+            </a:pPr>
+            <a:r>
+              <a:t>ISLAMIC REPUBLIC OF PAKISTAN  •  MINISTRY OF INTERIOR &amp; NARCOTICS CONTROL</a:t>
+            </a:r>
+          </a:p>
+        </p:txBody>
+      </p:sp>
+      <p:sp>
+        <p:nvSpPr>
+          <p:cNvPr id="5" name="Rounded Rectangle 4"/>
+          <p:cNvSpPr/>
+          <p:nvPr/>
+        </p:nvSpPr>
+        <p:spPr>
+          <a:xfrm>
+            <a:off x="914400" y="1508760"/>
+            <a:ext cx="3840480" cy="4480560"/>
+          </a:xfrm>
+          <a:prstGeom prst="roundRect">
+            <a:avLst/>
+          </a:prstGeom>
+          <a:solidFill>
+            <a:srgbClr val="122240"/>
+          </a:solidFill>
+          <a:ln w="19050">
+            <a:solidFill>
+              <a:srgbClr val="38BDF8"/>
+            </a:solidFill>
+          </a:ln>
+        </p:spPr>
+        <p:style>
+          <a:lnRef idx="1">
+            <a:schemeClr val="accent1"/>
+          </a:lnRef>
+          <a:fillRef idx="3">
+            <a:schemeClr val="accent1"/>
+          </a:fillRef>
+          <a:effectRef idx="2">
+            <a:schemeClr val="accent1"/>
+          </a:effectRef>
+          <a:fontRef idx="minor">
+            <a:schemeClr val="lt1"/>
+          </a:fontRef>
+        </p:style>
+        <p:txBody>
+          <a:bodyPr rtlCol="0" anchor="ctr"/>
+          <a:lstStyle/>
+          <a:p>
+            <a:pPr algn="ctr"/>
+          </a:p>
+        </p:txBody>
+      </p:sp>
+      <p:sp>
+        <p:nvSpPr>
+          <p:cNvPr id="6" name="Oval 5"/>
+          <p:cNvSpPr/>
+          <p:nvPr/>
+        </p:nvSpPr>
+        <p:spPr>
+          <a:xfrm>
+            <a:off x="1554480" y="1828800"/>
+            <a:ext cx="2560320" cy="2560320"/>
           </a:xfrm>
           <a:prstGeom prst="ellipse">
             <a:avLst/>
@@ -3189,7 +3334,7 @@
       </p:sp>
       <p:pic>
         <p:nvPicPr>
-          <p:cNvPr id="4" name="Picture 3" descr="images.jpg"/>
+          <p:cNvPr id="7" name="Picture 6" descr="images.jpg"/>
           <p:cNvPicPr>
             <a:picLocks noChangeAspect="1"/>
           </p:cNvPicPr>
@@ -3203,8 +3348,8 @@
         </p:blipFill>
         <p:spPr>
           <a:xfrm>
-            <a:off x="4998567" y="731520"/>
-            <a:ext cx="2194560" cy="2194560"/>
+            <a:off x="1600200" y="1874519"/>
+            <a:ext cx="2468880" cy="2468880"/>
           </a:xfrm>
           <a:prstGeom prst="rect">
             <a:avLst/>
@@ -3213,14 +3358,14 @@
       </p:pic>
       <p:sp>
         <p:nvSpPr>
-          <p:cNvPr id="5" name="TextBox 4"/>
+          <p:cNvPr id="8" name="TextBox 7"/>
           <p:cNvSpPr txBox="1"/>
           <p:nvPr/>
         </p:nvSpPr>
         <p:spPr>
           <a:xfrm>
-            <a:off x="914400" y="3108960"/>
-            <a:ext cx="10362895" cy="3383280"/>
+            <a:off x="1051560" y="4617720"/>
+            <a:ext cx="3566160" cy="1188720"/>
           </a:xfrm>
           <a:prstGeom prst="rect">
             <a:avLst/>
@@ -3234,23 +3379,223 @@
           <a:lstStyle/>
           <a:p>
             <a:pPr algn="ctr">
-              <a:defRPr sz="2800" b="1">
+              <a:defRPr sz="1200" b="1">
                 <a:solidFill>
                   <a:srgbClr val="E5B953"/>
                 </a:solidFill>
+                <a:latin typeface="Segoe UI"/>
+              </a:defRPr>
+            </a:pPr>
+            <a:r>
+              <a:t>OFFICIAL EMBLEM</a:t>
+            </a:r>
+          </a:p>
+          <a:p>
+            <a:pPr algn="ctr">
+              <a:spcBef>
+                <a:spcPts val="300"/>
+              </a:spcBef>
+              <a:defRPr sz="1000">
+                <a:solidFill>
+                  <a:srgbClr val="A0AEC0"/>
+                </a:solidFill>
+                <a:latin typeface="Segoe UI"/>
+              </a:defRPr>
+            </a:pPr>
+            <a:r>
+              <a:t>Combating Cyber Crimes</a:t>
+            </a:r>
+            <a:br/>
+            <a:r>
+              <a:t>Federal Investigation Authority</a:t>
+            </a:r>
+          </a:p>
+        </p:txBody>
+      </p:sp>
+      <p:sp>
+        <p:nvSpPr>
+          <p:cNvPr id="9" name="Rounded Rectangle 8"/>
+          <p:cNvSpPr/>
+          <p:nvPr/>
+        </p:nvSpPr>
+        <p:spPr>
+          <a:xfrm>
+            <a:off x="4983480" y="1508760"/>
+            <a:ext cx="6291072" cy="4480560"/>
+          </a:xfrm>
+          <a:prstGeom prst="roundRect">
+            <a:avLst/>
+          </a:prstGeom>
+          <a:solidFill>
+            <a:srgbClr val="122240"/>
+          </a:solidFill>
+          <a:ln w="19050">
+            <a:solidFill>
+              <a:srgbClr val="294A6E"/>
+            </a:solidFill>
+          </a:ln>
+        </p:spPr>
+        <p:style>
+          <a:lnRef idx="1">
+            <a:schemeClr val="accent1"/>
+          </a:lnRef>
+          <a:fillRef idx="3">
+            <a:schemeClr val="accent1"/>
+          </a:fillRef>
+          <a:effectRef idx="2">
+            <a:schemeClr val="accent1"/>
+          </a:effectRef>
+          <a:fontRef idx="minor">
+            <a:schemeClr val="lt1"/>
+          </a:fontRef>
+        </p:style>
+        <p:txBody>
+          <a:bodyPr rtlCol="0" anchor="ctr"/>
+          <a:lstStyle/>
+          <a:p>
+            <a:pPr algn="ctr"/>
+          </a:p>
+        </p:txBody>
+      </p:sp>
+      <p:sp>
+        <p:nvSpPr>
+          <p:cNvPr id="10" name="TextBox 9"/>
+          <p:cNvSpPr txBox="1"/>
+          <p:nvPr/>
+        </p:nvSpPr>
+        <p:spPr>
+          <a:xfrm>
+            <a:off x="5257800" y="1691640"/>
+            <a:ext cx="5760720" cy="2926080"/>
+          </a:xfrm>
+          <a:prstGeom prst="rect">
+            <a:avLst/>
+          </a:prstGeom>
+          <a:noFill/>
+        </p:spPr>
+        <p:txBody>
+          <a:bodyPr wrap="square">
+            <a:spAutoFit/>
+          </a:bodyPr>
+          <a:lstStyle/>
+          <a:p>
+            <a:pPr>
+              <a:defRPr sz="2600" b="1">
+                <a:solidFill>
+                  <a:srgbClr val="E5B953"/>
+                </a:solidFill>
                 <a:latin typeface="Georgia"/>
               </a:defRPr>
             </a:pPr>
             <a:r>
-              <a:t>NATIONAL CYBER CRIME INVESTIGATION AGENCY</a:t>
-            </a:r>
-          </a:p>
-          <a:p>
-            <a:pPr algn="ctr">
+              <a:t>NATIONAL CYBER CRIME</a:t>
+            </a:r>
+            <a:br/>
+            <a:r>
+              <a:t>INVESTIGATION AGENCY</a:t>
+            </a:r>
+          </a:p>
+          <a:p>
+            <a:pPr>
+              <a:spcBef>
+                <a:spcPts val="600"/>
+              </a:spcBef>
+              <a:defRPr sz="1500" b="1">
+                <a:solidFill>
+                  <a:srgbClr val="FFFFFF"/>
+                </a:solidFill>
+                <a:latin typeface="Segoe UI"/>
+              </a:defRPr>
+            </a:pPr>
+            <a:r>
+              <a:t>قومی سائبر کرائم تفتیش ایجنسی — حکومت پاکستان</a:t>
+            </a:r>
+          </a:p>
+        </p:txBody>
+      </p:sp>
+      <p:sp>
+        <p:nvSpPr>
+          <p:cNvPr id="11" name="Rectangle 10"/>
+          <p:cNvSpPr/>
+          <p:nvPr/>
+        </p:nvSpPr>
+        <p:spPr>
+          <a:xfrm>
+            <a:off x="5257800" y="3246120"/>
+            <a:ext cx="5715000" cy="36576"/>
+          </a:xfrm>
+          <a:prstGeom prst="rect">
+            <a:avLst/>
+          </a:prstGeom>
+          <a:solidFill>
+            <a:srgbClr val="E5B953"/>
+          </a:solidFill>
+          <a:ln>
+            <a:noFill/>
+          </a:ln>
+        </p:spPr>
+        <p:style>
+          <a:lnRef idx="1">
+            <a:schemeClr val="accent1"/>
+          </a:lnRef>
+          <a:fillRef idx="3">
+            <a:schemeClr val="accent1"/>
+          </a:fillRef>
+          <a:effectRef idx="2">
+            <a:schemeClr val="accent1"/>
+          </a:effectRef>
+          <a:fontRef idx="minor">
+            <a:schemeClr val="lt1"/>
+          </a:fontRef>
+        </p:style>
+        <p:txBody>
+          <a:bodyPr rtlCol="0" anchor="ctr"/>
+          <a:lstStyle/>
+          <a:p>
+            <a:pPr algn="ctr"/>
+          </a:p>
+        </p:txBody>
+      </p:sp>
+      <p:sp>
+        <p:nvSpPr>
+          <p:cNvPr id="12" name="TextBox 11"/>
+          <p:cNvSpPr txBox="1"/>
+          <p:nvPr/>
+        </p:nvSpPr>
+        <p:spPr>
+          <a:xfrm>
+            <a:off x="5257800" y="3364992"/>
+            <a:ext cx="5760720" cy="1280160"/>
+          </a:xfrm>
+          <a:prstGeom prst="rect">
+            <a:avLst/>
+          </a:prstGeom>
+          <a:noFill/>
+        </p:spPr>
+        <p:txBody>
+          <a:bodyPr wrap="square">
+            <a:spAutoFit/>
+          </a:bodyPr>
+          <a:lstStyle/>
+          <a:p>
+            <a:pPr>
+              <a:defRPr sz="1800" b="1">
+                <a:solidFill>
+                  <a:srgbClr val="38BDF8"/>
+                </a:solidFill>
+                <a:latin typeface="Segoe UI"/>
+              </a:defRPr>
+            </a:pPr>
+            <a:r>
+              <a:t>DIGITAL CASE MANAGEMENT SYSTEM (CMS)</a:t>
+            </a:r>
+          </a:p>
+          <a:p>
+            <a:pPr>
               <a:spcBef>
                 <a:spcPts val="400"/>
               </a:spcBef>
-              <a:defRPr sz="1500" b="1">
+              <a:defRPr sz="1200" b="1">
                 <a:solidFill>
                   <a:srgbClr val="FFFFFF"/>
                 </a:solidFill>
@@ -3258,39 +3603,172 @@
               </a:defRPr>
             </a:pPr>
             <a:r>
-              <a:t>قومی سائبر کرائم تفتیش ایجنسی — وزارت داخلہ حکومت پاکستان</a:t>
-            </a:r>
-          </a:p>
+              <a:t>Standard Operating Procedures (SOPs) &amp; Officer Operational Training Manual</a:t>
+            </a:r>
+          </a:p>
+        </p:txBody>
+      </p:sp>
+      <p:sp>
+        <p:nvSpPr>
+          <p:cNvPr id="13" name="Rounded Rectangle 12"/>
+          <p:cNvSpPr/>
+          <p:nvPr/>
+        </p:nvSpPr>
+        <p:spPr>
+          <a:xfrm>
+            <a:off x="5257800" y="5166360"/>
+            <a:ext cx="1828800" cy="594360"/>
+          </a:xfrm>
+          <a:prstGeom prst="roundRect">
+            <a:avLst/>
+          </a:prstGeom>
+          <a:solidFill>
+            <a:srgbClr val="0A162C"/>
+          </a:solidFill>
+          <a:ln w="15240">
+            <a:solidFill>
+              <a:srgbClr val="38BDF8"/>
+            </a:solidFill>
+          </a:ln>
+        </p:spPr>
+        <p:style>
+          <a:lnRef idx="1">
+            <a:schemeClr val="accent1"/>
+          </a:lnRef>
+          <a:fillRef idx="3">
+            <a:schemeClr val="accent1"/>
+          </a:fillRef>
+          <a:effectRef idx="2">
+            <a:schemeClr val="accent1"/>
+          </a:effectRef>
+          <a:fontRef idx="minor">
+            <a:schemeClr val="lt1"/>
+          </a:fontRef>
+        </p:style>
+        <p:txBody>
+          <a:bodyPr rtlCol="0" anchor="ctr" wrap="square" tIns="73152"/>
+          <a:lstStyle/>
           <a:p>
             <a:pPr algn="ctr">
-              <a:spcBef>
-                <a:spcPts val="1000"/>
-              </a:spcBef>
-              <a:defRPr sz="2000" b="1">
-                <a:solidFill>
-                  <a:srgbClr val="38BDF8"/>
-                </a:solidFill>
-                <a:latin typeface="Segoe UI"/>
-              </a:defRPr>
-            </a:pPr>
-            <a:r>
-              <a:t>Case Management System (CMS) — Officer Operational &amp; Training Guide</a:t>
-            </a:r>
-          </a:p>
+              <a:defRPr sz="950" b="1">
+                <a:solidFill>
+                  <a:srgbClr val="FFFFFF"/>
+                </a:solidFill>
+                <a:latin typeface="Segoe UI"/>
+              </a:defRPr>
+            </a:pPr>
+            <a:r>
+              <a:t>📝 Front Desk &amp; 80mm Slips</a:t>
+            </a:r>
+          </a:p>
+        </p:txBody>
+      </p:sp>
+      <p:sp>
+        <p:nvSpPr>
+          <p:cNvPr id="14" name="Rounded Rectangle 13"/>
+          <p:cNvSpPr/>
+          <p:nvPr/>
+        </p:nvSpPr>
+        <p:spPr>
+          <a:xfrm>
+            <a:off x="7178040" y="5166360"/>
+            <a:ext cx="1828800" cy="594360"/>
+          </a:xfrm>
+          <a:prstGeom prst="roundRect">
+            <a:avLst/>
+          </a:prstGeom>
+          <a:solidFill>
+            <a:srgbClr val="0A162C"/>
+          </a:solidFill>
+          <a:ln w="15240">
+            <a:solidFill>
+              <a:srgbClr val="E5B953"/>
+            </a:solidFill>
+          </a:ln>
+        </p:spPr>
+        <p:style>
+          <a:lnRef idx="1">
+            <a:schemeClr val="accent1"/>
+          </a:lnRef>
+          <a:fillRef idx="3">
+            <a:schemeClr val="accent1"/>
+          </a:fillRef>
+          <a:effectRef idx="2">
+            <a:schemeClr val="accent1"/>
+          </a:effectRef>
+          <a:fontRef idx="minor">
+            <a:schemeClr val="lt1"/>
+          </a:fontRef>
+        </p:style>
+        <p:txBody>
+          <a:bodyPr rtlCol="0" anchor="ctr" wrap="square" tIns="73152"/>
+          <a:lstStyle/>
           <a:p>
             <a:pPr algn="ctr">
-              <a:spcBef>
-                <a:spcPts val="600"/>
-              </a:spcBef>
-              <a:defRPr sz="1300">
-                <a:solidFill>
-                  <a:srgbClr val="A0AEC0"/>
-                </a:solidFill>
-                <a:latin typeface="Segoe UI"/>
-              </a:defRPr>
-            </a:pPr>
-            <a:r>
-              <a:t>A Complete Practical Manual for Desk Operators, Circle Incharges, VOs, IOs &amp; Forensic Experts</a:t>
+              <a:defRPr sz="950" b="1">
+                <a:solidFill>
+                  <a:srgbClr val="FFFFFF"/>
+                </a:solidFill>
+                <a:latin typeface="Segoe UI"/>
+              </a:defRPr>
+            </a:pPr>
+            <a:r>
+              <a:t>⚖️ VO &amp; IO Case Enquiries</a:t>
+            </a:r>
+          </a:p>
+        </p:txBody>
+      </p:sp>
+      <p:sp>
+        <p:nvSpPr>
+          <p:cNvPr id="15" name="Rounded Rectangle 14"/>
+          <p:cNvSpPr/>
+          <p:nvPr/>
+        </p:nvSpPr>
+        <p:spPr>
+          <a:xfrm>
+            <a:off x="9098280" y="5166360"/>
+            <a:ext cx="1828800" cy="594360"/>
+          </a:xfrm>
+          <a:prstGeom prst="roundRect">
+            <a:avLst/>
+          </a:prstGeom>
+          <a:solidFill>
+            <a:srgbClr val="0A162C"/>
+          </a:solidFill>
+          <a:ln w="15240">
+            <a:solidFill>
+              <a:srgbClr val="10955D"/>
+            </a:solidFill>
+          </a:ln>
+        </p:spPr>
+        <p:style>
+          <a:lnRef idx="1">
+            <a:schemeClr val="accent1"/>
+          </a:lnRef>
+          <a:fillRef idx="3">
+            <a:schemeClr val="accent1"/>
+          </a:fillRef>
+          <a:effectRef idx="2">
+            <a:schemeClr val="accent1"/>
+          </a:effectRef>
+          <a:fontRef idx="minor">
+            <a:schemeClr val="lt1"/>
+          </a:fontRef>
+        </p:style>
+        <p:txBody>
+          <a:bodyPr rtlCol="0" anchor="ctr" wrap="square" tIns="73152"/>
+          <a:lstStyle/>
+          <a:p>
+            <a:pPr algn="ctr">
+              <a:defRPr sz="950" b="1">
+                <a:solidFill>
+                  <a:srgbClr val="FFFFFF"/>
+                </a:solidFill>
+                <a:latin typeface="Segoe UI"/>
+              </a:defRPr>
+            </a:pPr>
+            <a:r>
+              <a:t>🔬 Digital Forensic Lab</a:t>
             </a:r>
           </a:p>
         </p:txBody>

</xml_diff>

<commit_message>
Apply 100% antialiased transparent circular mask to NCCIA logo and update presentation
</commit_message>
<xml_diff>
--- a/NCCIA_Officer_Operational_CMS_Presentation.pptx
+++ b/NCCIA_Officer_Operational_CMS_Presentation.pptx
@@ -3297,8 +3297,8 @@
         </p:nvSpPr>
         <p:spPr>
           <a:xfrm>
-            <a:off x="1554480" y="1828800"/>
-            <a:ext cx="2560320" cy="2560320"/>
+            <a:off x="1417320" y="1783080"/>
+            <a:ext cx="2834640" cy="2834640"/>
           </a:xfrm>
           <a:prstGeom prst="ellipse">
             <a:avLst/>
@@ -3332,9 +3332,54 @@
           </a:p>
         </p:txBody>
       </p:sp>
+      <p:sp>
+        <p:nvSpPr>
+          <p:cNvPr id="7" name="Oval 6"/>
+          <p:cNvSpPr/>
+          <p:nvPr/>
+        </p:nvSpPr>
+        <p:spPr>
+          <a:xfrm>
+            <a:off x="1490472" y="1856231"/>
+            <a:ext cx="2688336" cy="2688336"/>
+          </a:xfrm>
+          <a:prstGeom prst="ellipse">
+            <a:avLst/>
+          </a:prstGeom>
+          <a:solidFill>
+            <a:srgbClr val="0A162C"/>
+          </a:solidFill>
+          <a:ln w="19050">
+            <a:solidFill>
+              <a:srgbClr val="38BDF8"/>
+            </a:solidFill>
+          </a:ln>
+        </p:spPr>
+        <p:style>
+          <a:lnRef idx="1">
+            <a:schemeClr val="accent1"/>
+          </a:lnRef>
+          <a:fillRef idx="3">
+            <a:schemeClr val="accent1"/>
+          </a:fillRef>
+          <a:effectRef idx="2">
+            <a:schemeClr val="accent1"/>
+          </a:effectRef>
+          <a:fontRef idx="minor">
+            <a:schemeClr val="lt1"/>
+          </a:fontRef>
+        </p:style>
+        <p:txBody>
+          <a:bodyPr rtlCol="0" anchor="ctr"/>
+          <a:lstStyle/>
+          <a:p>
+            <a:pPr algn="ctr"/>
+          </a:p>
+        </p:txBody>
+      </p:sp>
       <p:pic>
         <p:nvPicPr>
-          <p:cNvPr id="7" name="Picture 6" descr="images.jpg"/>
+          <p:cNvPr id="8" name="Picture 7" descr="nccia_circle_logo.png"/>
           <p:cNvPicPr>
             <a:picLocks noChangeAspect="1"/>
           </p:cNvPicPr>
@@ -3348,8 +3393,8 @@
         </p:blipFill>
         <p:spPr>
           <a:xfrm>
-            <a:off x="1600200" y="1874519"/>
-            <a:ext cx="2468880" cy="2468880"/>
+            <a:off x="1554480" y="1920240"/>
+            <a:ext cx="2560320" cy="2560320"/>
           </a:xfrm>
           <a:prstGeom prst="rect">
             <a:avLst/>
@@ -3358,7 +3403,7 @@
       </p:pic>
       <p:sp>
         <p:nvSpPr>
-          <p:cNvPr id="8" name="TextBox 7"/>
+          <p:cNvPr id="9" name="TextBox 8"/>
           <p:cNvSpPr txBox="1"/>
           <p:nvPr/>
         </p:nvSpPr>
@@ -3414,7 +3459,7 @@
       </p:sp>
       <p:sp>
         <p:nvSpPr>
-          <p:cNvPr id="9" name="Rounded Rectangle 8"/>
+          <p:cNvPr id="10" name="Rounded Rectangle 9"/>
           <p:cNvSpPr/>
           <p:nvPr/>
         </p:nvSpPr>
@@ -3459,7 +3504,7 @@
       </p:sp>
       <p:sp>
         <p:nvSpPr>
-          <p:cNvPr id="10" name="TextBox 9"/>
+          <p:cNvPr id="11" name="TextBox 10"/>
           <p:cNvSpPr txBox="1"/>
           <p:nvPr/>
         </p:nvSpPr>
@@ -3515,7 +3560,7 @@
       </p:sp>
       <p:sp>
         <p:nvSpPr>
-          <p:cNvPr id="11" name="Rectangle 10"/>
+          <p:cNvPr id="12" name="Rectangle 11"/>
           <p:cNvSpPr/>
           <p:nvPr/>
         </p:nvSpPr>
@@ -3558,7 +3603,7 @@
       </p:sp>
       <p:sp>
         <p:nvSpPr>
-          <p:cNvPr id="12" name="TextBox 11"/>
+          <p:cNvPr id="13" name="TextBox 12"/>
           <p:cNvSpPr txBox="1"/>
           <p:nvPr/>
         </p:nvSpPr>
@@ -3610,7 +3655,7 @@
       </p:sp>
       <p:sp>
         <p:nvSpPr>
-          <p:cNvPr id="13" name="Rounded Rectangle 12"/>
+          <p:cNvPr id="14" name="Rounded Rectangle 13"/>
           <p:cNvSpPr/>
           <p:nvPr/>
         </p:nvSpPr>
@@ -3665,7 +3710,7 @@
       </p:sp>
       <p:sp>
         <p:nvSpPr>
-          <p:cNvPr id="14" name="Rounded Rectangle 13"/>
+          <p:cNvPr id="15" name="Rounded Rectangle 14"/>
           <p:cNvSpPr/>
           <p:nvPr/>
         </p:nvSpPr>
@@ -3720,7 +3765,7 @@
       </p:sp>
       <p:sp>
         <p:nvSpPr>
-          <p:cNvPr id="15" name="Rounded Rectangle 14"/>
+          <p:cNvPr id="16" name="Rounded Rectangle 15"/>
           <p:cNvSpPr/>
           <p:nvPr/>
         </p:nvSpPr>
@@ -3888,7 +3933,7 @@
       </p:sp>
       <p:pic>
         <p:nvPicPr>
-          <p:cNvPr id="4" name="Picture 3" descr="images.jpg"/>
+          <p:cNvPr id="4" name="Picture 3" descr="nccia_circle_logo.png"/>
           <p:cNvPicPr>
             <a:picLocks noChangeAspect="1"/>
           </p:cNvPicPr>
@@ -3903,7 +3948,7 @@
         <p:spPr>
           <a:xfrm>
             <a:off x="10972800" y="274320"/>
-            <a:ext cx="919655" cy="960120"/>
+            <a:ext cx="960120" cy="960120"/>
           </a:xfrm>
           <a:prstGeom prst="rect">
             <a:avLst/>
@@ -4361,7 +4406,7 @@
       </p:sp>
       <p:pic>
         <p:nvPicPr>
-          <p:cNvPr id="4" name="Picture 3" descr="images.jpg"/>
+          <p:cNvPr id="4" name="Picture 3" descr="nccia_circle_logo.png"/>
           <p:cNvPicPr>
             <a:picLocks noChangeAspect="1"/>
           </p:cNvPicPr>
@@ -4376,7 +4421,7 @@
         <p:spPr>
           <a:xfrm>
             <a:off x="10972800" y="274320"/>
-            <a:ext cx="919655" cy="960120"/>
+            <a:ext cx="960120" cy="960120"/>
           </a:xfrm>
           <a:prstGeom prst="rect">
             <a:avLst/>
@@ -4834,7 +4879,7 @@
       </p:sp>
       <p:pic>
         <p:nvPicPr>
-          <p:cNvPr id="4" name="Picture 3" descr="images.jpg"/>
+          <p:cNvPr id="4" name="Picture 3" descr="nccia_circle_logo.png"/>
           <p:cNvPicPr>
             <a:picLocks noChangeAspect="1"/>
           </p:cNvPicPr>
@@ -4849,7 +4894,7 @@
         <p:spPr>
           <a:xfrm>
             <a:off x="10972800" y="274320"/>
-            <a:ext cx="919655" cy="960120"/>
+            <a:ext cx="960120" cy="960120"/>
           </a:xfrm>
           <a:prstGeom prst="rect">
             <a:avLst/>
@@ -5307,7 +5352,7 @@
       </p:sp>
       <p:pic>
         <p:nvPicPr>
-          <p:cNvPr id="4" name="Picture 3" descr="images.jpg"/>
+          <p:cNvPr id="4" name="Picture 3" descr="nccia_circle_logo.png"/>
           <p:cNvPicPr>
             <a:picLocks noChangeAspect="1"/>
           </p:cNvPicPr>
@@ -5322,7 +5367,7 @@
         <p:spPr>
           <a:xfrm>
             <a:off x="10972800" y="274320"/>
-            <a:ext cx="919655" cy="960120"/>
+            <a:ext cx="960120" cy="960120"/>
           </a:xfrm>
           <a:prstGeom prst="rect">
             <a:avLst/>
@@ -6146,7 +6191,7 @@
       </p:sp>
       <p:pic>
         <p:nvPicPr>
-          <p:cNvPr id="4" name="Picture 3" descr="images.jpg"/>
+          <p:cNvPr id="4" name="Picture 3" descr="nccia_circle_logo.png"/>
           <p:cNvPicPr>
             <a:picLocks noChangeAspect="1"/>
           </p:cNvPicPr>
@@ -6161,7 +6206,7 @@
         <p:spPr>
           <a:xfrm>
             <a:off x="10972800" y="274320"/>
-            <a:ext cx="919655" cy="960120"/>
+            <a:ext cx="960120" cy="960120"/>
           </a:xfrm>
           <a:prstGeom prst="rect">
             <a:avLst/>
@@ -6467,7 +6512,7 @@
       </p:sp>
       <p:pic>
         <p:nvPicPr>
-          <p:cNvPr id="4" name="Picture 3" descr="images.jpg"/>
+          <p:cNvPr id="4" name="Picture 3" descr="nccia_circle_logo.png"/>
           <p:cNvPicPr>
             <a:picLocks noChangeAspect="1"/>
           </p:cNvPicPr>
@@ -6482,7 +6527,7 @@
         <p:spPr>
           <a:xfrm>
             <a:off x="10972800" y="274320"/>
-            <a:ext cx="919655" cy="960120"/>
+            <a:ext cx="960120" cy="960120"/>
           </a:xfrm>
           <a:prstGeom prst="rect">
             <a:avLst/>
@@ -7072,7 +7117,7 @@
       </p:sp>
       <p:pic>
         <p:nvPicPr>
-          <p:cNvPr id="4" name="Picture 3" descr="images.jpg"/>
+          <p:cNvPr id="4" name="Picture 3" descr="nccia_circle_logo.png"/>
           <p:cNvPicPr>
             <a:picLocks noChangeAspect="1"/>
           </p:cNvPicPr>
@@ -7087,7 +7132,7 @@
         <p:spPr>
           <a:xfrm>
             <a:off x="10972800" y="274320"/>
-            <a:ext cx="919655" cy="960120"/>
+            <a:ext cx="960120" cy="960120"/>
           </a:xfrm>
           <a:prstGeom prst="rect">
             <a:avLst/>
@@ -7989,7 +8034,7 @@
       </p:sp>
       <p:pic>
         <p:nvPicPr>
-          <p:cNvPr id="4" name="Picture 3" descr="images.jpg"/>
+          <p:cNvPr id="4" name="Picture 3" descr="nccia_circle_logo.png"/>
           <p:cNvPicPr>
             <a:picLocks noChangeAspect="1"/>
           </p:cNvPicPr>
@@ -8004,7 +8049,7 @@
         <p:spPr>
           <a:xfrm>
             <a:off x="10972800" y="274320"/>
-            <a:ext cx="919655" cy="960120"/>
+            <a:ext cx="960120" cy="960120"/>
           </a:xfrm>
           <a:prstGeom prst="rect">
             <a:avLst/>
@@ -8494,7 +8539,7 @@
       </p:sp>
       <p:pic>
         <p:nvPicPr>
-          <p:cNvPr id="4" name="Picture 3" descr="images.jpg"/>
+          <p:cNvPr id="4" name="Picture 3" descr="nccia_circle_logo.png"/>
           <p:cNvPicPr>
             <a:picLocks noChangeAspect="1"/>
           </p:cNvPicPr>
@@ -8509,7 +8554,7 @@
         <p:spPr>
           <a:xfrm>
             <a:off x="10972800" y="274320"/>
-            <a:ext cx="919655" cy="960120"/>
+            <a:ext cx="960120" cy="960120"/>
           </a:xfrm>
           <a:prstGeom prst="rect">
             <a:avLst/>
@@ -8967,7 +9012,7 @@
       </p:sp>
       <p:pic>
         <p:nvPicPr>
-          <p:cNvPr id="4" name="Picture 3" descr="images.jpg"/>
+          <p:cNvPr id="4" name="Picture 3" descr="nccia_circle_logo.png"/>
           <p:cNvPicPr>
             <a:picLocks noChangeAspect="1"/>
           </p:cNvPicPr>
@@ -8982,7 +9027,7 @@
         <p:spPr>
           <a:xfrm>
             <a:off x="10972800" y="274320"/>
-            <a:ext cx="919655" cy="960120"/>
+            <a:ext cx="960120" cy="960120"/>
           </a:xfrm>
           <a:prstGeom prst="rect">
             <a:avLst/>
@@ -9472,7 +9517,7 @@
       </p:sp>
       <p:pic>
         <p:nvPicPr>
-          <p:cNvPr id="4" name="Picture 3" descr="images.jpg"/>
+          <p:cNvPr id="4" name="Picture 3" descr="nccia_circle_logo.png"/>
           <p:cNvPicPr>
             <a:picLocks noChangeAspect="1"/>
           </p:cNvPicPr>
@@ -9487,7 +9532,7 @@
         <p:spPr>
           <a:xfrm>
             <a:off x="10972800" y="274320"/>
-            <a:ext cx="919655" cy="960120"/>
+            <a:ext cx="960120" cy="960120"/>
           </a:xfrm>
           <a:prstGeom prst="rect">
             <a:avLst/>
@@ -9945,7 +9990,7 @@
       </p:sp>
       <p:pic>
         <p:nvPicPr>
-          <p:cNvPr id="4" name="Picture 3" descr="images.jpg"/>
+          <p:cNvPr id="4" name="Picture 3" descr="nccia_circle_logo.png"/>
           <p:cNvPicPr>
             <a:picLocks noChangeAspect="1"/>
           </p:cNvPicPr>
@@ -9960,7 +10005,7 @@
         <p:spPr>
           <a:xfrm>
             <a:off x="10972800" y="274320"/>
-            <a:ext cx="919655" cy="960120"/>
+            <a:ext cx="960120" cy="960120"/>
           </a:xfrm>
           <a:prstGeom prst="rect">
             <a:avLst/>
@@ -10418,7 +10463,7 @@
       </p:sp>
       <p:pic>
         <p:nvPicPr>
-          <p:cNvPr id="4" name="Picture 3" descr="images.jpg"/>
+          <p:cNvPr id="4" name="Picture 3" descr="nccia_circle_logo.png"/>
           <p:cNvPicPr>
             <a:picLocks noChangeAspect="1"/>
           </p:cNvPicPr>
@@ -10433,7 +10478,7 @@
         <p:spPr>
           <a:xfrm>
             <a:off x="10972800" y="274320"/>
-            <a:ext cx="919655" cy="960120"/>
+            <a:ext cx="960120" cy="960120"/>
           </a:xfrm>
           <a:prstGeom prst="rect">
             <a:avLst/>

</xml_diff>